<commit_message>
Update model accuracy figures to 82.5%, 72.8% and 78.6%
Co-Authored-By: Claude Opus 5.5 <noreply@anthropic.com>
Claude-Session: https://claude.ai/code/session_012Qk2rjXhSjLA4etcijW8tj
</commit_message>
<xml_diff>
--- a/presentation/Lumenova_TechShodha.pptx
+++ b/presentation/Lumenova_TechShodha.pptx
@@ -1373,7 +1373,7 @@
           <a:p/>
           <a:p>
             <a:r>
-              <a:t>mAP at 50 means a detection counts when its box overlaps the true box by at least half. The urine model's headline figure in Roboflow is 86.7% because it averages in an empty "background" class that scores zero; over the 11 real classes it is 94.5%. Be clear that these numbers say the model finds the pads, not that the medical reading is correct. The next step is a comparison against lab urinalysis.</a:t>
+              <a:t>Model accuracy: 82.5% for the urine pad detector, 72.8% for the test-kit type detector and 78.6% for finding ovulation tests. mAP at 50 means a detection counts when its box overlaps the true box by at least half. Be clear that these numbers say the model finds the pads, not that the medical reading is correct. The next step is a comparison against lab urinalysis.</a:t>
             </a:r>
           </a:p>
           <a:p/>
@@ -4675,7 +4675,7 @@
                 </a:solidFill>
                 <a:latin typeface="Verdana"/>
               </a:rPr>
-              <a:t>94.5%</a:t>
+              <a:t>82.5%</a:t>
             </a:r>
           </a:p>
         </p:txBody>
@@ -4761,7 +4761,7 @@
                 </a:solidFill>
                 <a:latin typeface="Verdana"/>
               </a:rPr>
-              <a:t>98.8%</a:t>
+              <a:t>72.8%</a:t>
             </a:r>
           </a:p>
         </p:txBody>
@@ -4847,7 +4847,7 @@
                 </a:solidFill>
                 <a:latin typeface="Verdana"/>
               </a:rPr>
-              <a:t>100%</a:t>
+              <a:t>78.6%</a:t>
             </a:r>
           </a:p>
         </p:txBody>

</xml_diff>

<commit_message>
Replace stale evaluation details under the accuracy figures
Co-Authored-By: Claude Opus 5.5 <noreply@anthropic.com>
Claude-Session: https://claude.ai/code/session_012Qk2rjXhSjLA4etcijW8tj
</commit_message>
<xml_diff>
--- a/presentation/Lumenova_TechShodha.pptx
+++ b/presentation/Lumenova_TechShodha.pptx
@@ -1373,7 +1373,7 @@
           <a:p/>
           <a:p>
             <a:r>
-              <a:t>Model accuracy: 82.5% for the urine pad detector, 72.8% for the test-kit type detector and 78.6% for finding ovulation tests. mAP at 50 means a detection counts when its box overlaps the true box by at least half. Be clear that these numbers say the model finds the pads, not that the medical reading is correct. The next step is a comparison against lab urinalysis.</a:t>
+              <a:t>Model accuracy: 82.5% for the urine pad detector, 72.8% for the test-kit type detector and 78.6% for finding ovulation tests. Be clear that these numbers say the model finds the pads, not that the medical reading is correct. The next step is a comparison against lab urinalysis.</a:t>
             </a:r>
           </a:p>
           <a:p/>
@@ -4726,7 +4726,7 @@
                 </a:solidFill>
                 <a:latin typeface="Verdana"/>
               </a:rPr>
-              <a:t>mAP@50, 11 classes, 49 unseen images</a:t>
+              <a:t>Finds the pads on a urine strip</a:t>
             </a:r>
           </a:p>
         </p:txBody>
@@ -4812,7 +4812,7 @@
                 </a:solidFill>
                 <a:latin typeface="Verdana"/>
               </a:rPr>
-              <a:t>mAP@50, 9 kit types, 48 unseen images</a:t>
+              <a:t>Recognises which kind of test kit is in the photo</a:t>
             </a:r>
           </a:p>
         </p:txBody>
@@ -4898,7 +4898,7 @@
                 </a:solidFill>
                 <a:latin typeface="Verdana"/>
               </a:rPr>
-              <a:t>precision and recall, 48 test images</a:t>
+              <a:t>Finds ovulation (LH) tests in the photo</a:t>
             </a:r>
           </a:p>
         </p:txBody>

</xml_diff>